<commit_message>
Update report and presentation: offline drafts, 60 tests, screenshots
- Report: offline listing drafts throughout (objective 4 achieved),
  48 backend tests, production fixes in Section 5.6, new system tests
  TC-18/19, and eight app screenshots in Appendix C
- Presentation: matching counts and statuses, red tamper warning in the
  demo step and screenshot

Co-Authored-By: Claude Opus 5.5 <noreply@anthropic.com>
Claude-Session: https://claude.ai/code/session_01TkMBnKe3c5H95DS4zcaeu8
</commit_message>
<xml_diff>
--- a/docs/presentation/ZamMarket_Presentation.pptx
+++ b/docs/presentation/ZamMarket_Presentation.pptx
@@ -705,7 +705,7 @@
           <a:lstStyle/>
           <a:p>
             <a:r>
-              <a:t>This table is the gap in one picture. Each platform covers part of the problem; none covers all four columns. Offline support for ZamMarket is marked partial, honestly: browsing and messages work offline, but creating a listing needs a connection.</a:t>
+              <a:t>This table is the gap in one picture. Each platform covers part of the problem; none covers all four columns. ZamMarket covers all four: browsing, messages and even new listings with photos keep working offline and are sent when the connection returns.</a:t>
             </a:r>
           </a:p>
         </p:txBody>
@@ -1335,7 +1335,7 @@
           <a:lstStyle/>
           <a:p>
             <a:r>
-              <a:t>This was an individual project, so I did all of the work myself, under Mr. Phiri's supervision. In numbers: four agile sprints plus a stabilisation period, eight modules, and 35 automated tests that all pass. The app covers eleven named Lusaka neighbourhoods.</a:t>
+              <a:t>This was an individual project, so I did all of the work myself, under Mr. Phiri's supervision. In numbers: four agile sprints plus a stabilisation period, eight modules, and 60 automated tests that all pass. The app covers eleven named Lusaka neighbourhoods.</a:t>
             </a:r>
           </a:p>
         </p:txBody>
@@ -2175,7 +2175,7 @@
           <a:lstStyle/>
           <a:p>
             <a:r>
-              <a:t>Three objectives fully achieved. Objective 4 is mostly achieved: chat and browsing work offline, but creating a listing still needs a connection. Objective 5 is partly achieved until the usability study is done.</a:t>
+              <a:t>Four objectives fully achieved, including offline support: listings created without a connection are saved with their photo and posted automatically on reconnection. Objective 5 is partly achieved until the usability study is done.</a:t>
             </a:r>
           </a:p>
         </p:txBody>
@@ -2315,7 +2315,7 @@
           <a:lstStyle/>
           <a:p>
             <a:r>
-              <a:t>The most important finding: you can give informal cash traders a verifiable reputation without online payment and without a real blockchain. Research question 1 is answered yes. Questions 2 and 3 are answered partly.</a:t>
+              <a:t>The most important finding: you can give informal cash traders a verifiable reputation without online payment and without a real blockchain. Research questions 1 and 3 are answered largely yes; question 2 partly, because of the language limit.</a:t>
             </a:r>
           </a:p>
         </p:txBody>
@@ -2595,7 +2595,7 @@
           <a:lstStyle/>
           <a:p>
             <a:r>
-              <a:t>Three achieved, one mostly achieved, one partly achieved, pending the user study.</a:t>
+              <a:t>Four achieved; the fifth is partly achieved, pending the user study.</a:t>
             </a:r>
           </a:p>
         </p:txBody>
@@ -2945,7 +2945,7 @@
           <a:lstStyle/>
           <a:p>
             <a:r>
-              <a:t>DEMO SCRIPT (about 4 minutes). Have two browser windows open before you start: a buyer logged in on one, the seller on the other (or a phone). 1) As buyer: Browse, tap Kanyama, set a price range. 2) As seller: New Listing, Voice, say 'Hardwood charcoal, ten bags, ninety five kwacha each, Kanyama'; show the fields, tap Use This, post. 3) As buyer: open the listing, Message Seller; reply as seller. Turn on airplane mode, send a message, show it queued; turn data back on and show it delivered. 4) As buyer: Rate Seller, 5 stars; open the trust page and show the new block. 5) In MongoDB Atlas, edit one trustchains document (change a rating type); refresh the trust page: 'Chain Invalid'. Undo the edit afterwards. 6) As admin: verify the seller; score rises by 15. If anything fails, fall back to the screenshots.</a:t>
+              <a:t>DEMO SCRIPT (about 4 minutes). Have two browser windows open before you start: a buyer logged in on one, the seller on the other (or a phone). 1) As buyer: Browse, tap Kanyama, set a price range. 2) As seller: New Listing, Voice, say 'Hardwood charcoal, ten bags, ninety five kwacha each, Kanyama'; show the fields, tap Use This, post. 3) As buyer: open the listing, Message Seller; reply as seller. Turn on airplane mode, send a message and post a listing with a photo; show both waiting (My Listings shows 'Waiting to post'); turn data back on and show both delivered. 4) As buyer: Rate Seller, 5 stars; open the trust page and show the new block. 5) In MongoDB Atlas, edit one trustchains document (change a rating type); refresh the trust page: the score turns into a red 'Record has been altered' warning. Undo the edit afterwards. 6) As admin: verify the seller; score rises by 15. If anything fails, fall back to the screenshots.</a:t>
             </a:r>
           </a:p>
         </p:txBody>
@@ -9406,11 +9406,11 @@
                       <a:r>
                         <a:rPr sz="1800" b="1">
                           <a:solidFill>
-                            <a:srgbClr val="B26B00"/>
+                            <a:srgbClr val="2E7D4F"/>
                           </a:solidFill>
                           <a:latin typeface="Calibri"/>
                         </a:rPr>
-                        <a:t>Partial</a:t>
+                        <a:t>✓</a:t>
                       </a:r>
                     </a:p>
                   </a:txBody>
@@ -14061,7 +14061,7 @@
                 </a:solidFill>
                 <a:latin typeface="Calibri"/>
               </a:rPr>
-              <a:t>35</a:t>
+              <a:t>60</a:t>
             </a:r>
           </a:p>
         </p:txBody>
@@ -20231,7 +20231,7 @@
                 </a:solidFill>
                 <a:latin typeface="Calibri"/>
               </a:rPr>
-              <a:t>35 automated tests, run on every push by GitHub Actions</a:t>
+              <a:t>60 automated tests, run on every push by GitHub Actions</a:t>
             </a:r>
           </a:p>
         </p:txBody>
@@ -22011,7 +22011,7 @@
                 </a:solidFill>
                 <a:latin typeface="Calibri"/>
               </a:rPr>
-              <a:t>All 23 backend and 12 voice-parser tests pass. Full tables: Report Tables 6.1 to 6.3.</a:t>
+              <a:t>All 48 backend and 12 voice-parser tests pass. Full tables: Report Tables 6.1 to 6.3.</a:t>
             </a:r>
           </a:p>
         </p:txBody>
@@ -22243,7 +22243,7 @@
                 </a:solidFill>
                 <a:latin typeface="Calibri"/>
               </a:rPr>
-              <a:t>23/23</a:t>
+              <a:t>48/48</a:t>
             </a:r>
           </a:p>
         </p:txBody>
@@ -24040,7 +24040,7 @@
                 </a:solidFill>
                 <a:latin typeface="Calibri"/>
               </a:rPr>
-              <a:t>23/23 tests incl. most recent block</a:t>
+              <a:t>48/48 tests incl. most recent block</a:t>
             </a:r>
           </a:p>
         </p:txBody>
@@ -24251,7 +24251,7 @@
                 </a:solidFill>
                 <a:latin typeface="Calibri"/>
               </a:rPr>
-              <a:t>Chat, offline queue, cached browsing</a:t>
+              <a:t>Chat, offline queue, offline listing drafts</a:t>
             </a:r>
           </a:p>
         </p:txBody>
@@ -24273,7 +24273,7 @@
             </a:avLst>
           </a:prstGeom>
           <a:solidFill>
-            <a:srgbClr val="FDF1DC"/>
+            <a:srgbClr val="E3F2E8"/>
           </a:solidFill>
           <a:ln>
             <a:noFill/>
@@ -24332,11 +24332,11 @@
             <a:r>
               <a:rPr sz="1300" b="1" i="0">
                 <a:solidFill>
-                  <a:srgbClr val="B26B00"/>
-                </a:solidFill>
-                <a:latin typeface="Calibri"/>
-              </a:rPr>
-              <a:t>Mostly achieved</a:t>
+                  <a:srgbClr val="2E7D4F"/>
+                </a:solidFill>
+                <a:latin typeface="Calibri"/>
+              </a:rPr>
+              <a:t>Achieved</a:t>
             </a:r>
           </a:p>
         </p:txBody>
@@ -25216,7 +25216,7 @@
                 </a:solidFill>
                 <a:latin typeface="Calibri"/>
               </a:rPr>
-              <a:t>35 automated tests, CI, browser checks, system test plan</a:t>
+              <a:t>60 automated tests, CI, browser checks, system test plan</a:t>
             </a:r>
           </a:p>
         </p:txBody>
@@ -26460,7 +26460,7 @@
             </a:avLst>
           </a:prstGeom>
           <a:solidFill>
-            <a:srgbClr val="FDF1DC"/>
+            <a:srgbClr val="E3F2E8"/>
           </a:solidFill>
           <a:ln>
             <a:noFill/>
@@ -26519,11 +26519,11 @@
             <a:r>
               <a:rPr sz="1300" b="1" i="0">
                 <a:solidFill>
-                  <a:srgbClr val="B26B00"/>
-                </a:solidFill>
-                <a:latin typeface="Calibri"/>
-              </a:rPr>
-              <a:t>RQ3: Partly</a:t>
+                  <a:srgbClr val="2E7D4F"/>
+                </a:solidFill>
+                <a:latin typeface="Calibri"/>
+              </a:rPr>
+              <a:t>RQ3: Largely</a:t>
             </a:r>
           </a:p>
         </p:txBody>
@@ -26562,7 +26562,7 @@
                 </a:solidFill>
                 <a:latin typeface="Calibri"/>
               </a:rPr>
-              <a:t>Reading and messaging survive drops; creating records needs a connection.</a:t>
+              <a:t>Reading, messaging and new listings survive drops; ratings need a connection.</a:t>
             </a:r>
           </a:p>
         </p:txBody>
@@ -28956,7 +28956,7 @@
                 </a:solidFill>
                 <a:latin typeface="Calibri"/>
               </a:rPr>
-              <a:t>35 of 35 automated tests pass; any tampering is detected</a:t>
+              <a:t>60 of 60 automated tests pass; any tampering is detected</a:t>
             </a:r>
           </a:p>
         </p:txBody>
@@ -29738,7 +29738,7 @@
             </a:avLst>
           </a:prstGeom>
           <a:solidFill>
-            <a:srgbClr val="FDF1DC"/>
+            <a:srgbClr val="E3F2E8"/>
           </a:solidFill>
           <a:ln>
             <a:noFill/>
@@ -29797,11 +29797,11 @@
             <a:r>
               <a:rPr sz="1300" b="1" i="0">
                 <a:solidFill>
-                  <a:srgbClr val="B26B00"/>
-                </a:solidFill>
-                <a:latin typeface="Calibri"/>
-              </a:rPr>
-              <a:t>Mostly</a:t>
+                  <a:srgbClr val="2E7D4F"/>
+                </a:solidFill>
+                <a:latin typeface="Calibri"/>
+              </a:rPr>
+              <a:t>Achieved</a:t>
             </a:r>
           </a:p>
         </p:txBody>
@@ -29879,7 +29879,7 @@
                 </a:solidFill>
                 <a:latin typeface="Calibri"/>
               </a:rPr>
-              <a:t>Chat and offline reading; offline listing creation not provided</a:t>
+              <a:t>Chat, offline reading and offline listing drafts</a:t>
             </a:r>
           </a:p>
         </p:txBody>
@@ -31005,7 +31005,7 @@
                 </a:solidFill>
                 <a:latin typeface="Calibri"/>
               </a:rPr>
-              <a:t>Offline listing drafts</a:t>
+              <a:t>Offline ratings</a:t>
             </a:r>
           </a:p>
         </p:txBody>
@@ -31044,7 +31044,7 @@
                 </a:solidFill>
                 <a:latin typeface="Calibri"/>
               </a:rPr>
-              <a:t>Save listings with photos offline; submit on reconnection</a:t>
+              <a:t>Queue ratings like messages, so buyers can rate without a signal</a:t>
             </a:r>
           </a:p>
         </p:txBody>
@@ -31979,7 +31979,7 @@
                 </a:solidFill>
                 <a:latin typeface="Calibri"/>
               </a:rPr>
-              <a:t>Real-time chat; send a message offline, then reconnect</a:t>
+              <a:t>Chat; go offline, send a message and post a listing, then reconnect</a:t>
             </a:r>
           </a:p>
         </p:txBody>
@@ -32241,7 +32241,7 @@
                 </a:solidFill>
                 <a:latin typeface="Calibri"/>
               </a:rPr>
-              <a:t>Edit a block in MongoDB Atlas: "Chain Invalid" appears</a:t>
+              <a:t>Edit a block in MongoDB Atlas: a red "Record has been altered" warning</a:t>
             </a:r>
           </a:p>
         </p:txBody>

</xml_diff>

<commit_message>
Update report and slides for the redesigned admin module
- Report: admin module, FR12, AdminLog collection, admin API routes, new
  challenges, tests B24-B27 and TC-20/21, test counts (60 backend, 72 total),
  admin screenshots in Appendix C
- Slides: test counts, admin module, AdminLog, challenges and demo step

Co-Authored-By: Claude Opus 5.5 <noreply@anthropic.com>
Claude-Session: https://claude.ai/code/session_01TkMBnKe3c5H95DS4zcaeu8
</commit_message>
<xml_diff>
--- a/docs/presentation/ZamMarket_Presentation.pptx
+++ b/docs/presentation/ZamMarket_Presentation.pptx
@@ -1265,7 +1265,7 @@
           <a:lstStyle/>
           <a:p>
             <a:r>
-              <a:t>Six MongoDB collections. Two design decisions to point out: each trust block is its own document, with a unique index on seller and position so two simultaneous events cannot fork the chain; and the latest hash is also stored on the user, which lets us detect edits to the most recent block.</a:t>
+              <a:t>Seven MongoDB collections. Two design decisions to point out: each trust block is its own document, with a unique index on seller and position so two simultaneous events cannot fork the chain; and the latest hash is also stored on the user, which lets us detect edits to the most recent block.</a:t>
             </a:r>
           </a:p>
         </p:txBody>
@@ -1335,7 +1335,7 @@
           <a:lstStyle/>
           <a:p>
             <a:r>
-              <a:t>This was an individual project, so I did all of the work myself, under Mr. Phiri's supervision. In numbers: four agile sprints plus a stabilisation period, eight modules, and 60 automated tests that all pass. The app covers eleven named Lusaka neighbourhoods.</a:t>
+              <a:t>This was an individual project, so I did all of the work myself, under Mr. Phiri's supervision. In numbers: four agile sprints plus a stabilisation period, eight modules, and 72 automated tests that all pass. The app covers eleven named Lusaka neighbourhoods.</a:t>
             </a:r>
           </a:p>
         </p:txBody>
@@ -2945,7 +2945,7 @@
           <a:lstStyle/>
           <a:p>
             <a:r>
-              <a:t>DEMO SCRIPT (about 4 minutes). Have two browser windows open before you start: a buyer logged in on one, the seller on the other (or a phone). 1) As buyer: Browse, tap Kanyama, set a price range. 2) As seller: New Listing, Voice, say 'Hardwood charcoal, ten bags, ninety five kwacha each, Kanyama'; show the fields, tap Use This, post. 3) As buyer: open the listing, Message Seller; reply as seller. Turn on airplane mode, send a message and post a listing with a photo; show both waiting (My Listings shows 'Waiting to post'); turn data back on and show both delivered. 4) As buyer: Rate Seller, 5 stars; open the trust page and show the new block. 5) In MongoDB Atlas, edit one trustchains document (change a rating type); refresh the trust page: the score turns into a red 'Record has been altered' warning. Undo the edit afterwards. 6) As admin: verify the seller; score rises by 15. If anything fails, fall back to the screenshots.</a:t>
+              <a:t>DEMO SCRIPT (about 4 minutes). Have two browser windows open before you start: a buyer logged in on one, the seller on the other (or a phone). 1) As buyer: Browse, tap Kanyama, set a price range. 2) As seller: New Listing, Voice, say 'Hardwood charcoal, ten bags, ninety five kwacha each, Kanyama'; show the fields, tap Use This, post. 3) As buyer: open the listing, Message Seller; reply as seller. Turn on airplane mode, send a message and post a listing with a photo; show both waiting (My Listings shows 'Waiting to post'); turn data back on and show both delivered. 4) As buyer: Rate Seller, 5 stars; open the trust page and show the new block. 5) In MongoDB Atlas, edit one trustchains document (change a rating type); refresh the trust page: the score turns into a red 'Record has been altered' warning. 6) As admin: open the Integrity tab; the same seller is flagged and the tab shows a red badge. Undo the edit in Atlas, run the check again and show it clear. Then open the Verify tab and verify a seller; their score rises by 15, and the action appears in the Activity tab. If anything fails, fall back to the screenshots.</a:t>
             </a:r>
           </a:p>
         </p:txBody>
@@ -14061,7 +14061,7 @@
                 </a:solidFill>
                 <a:latin typeface="Calibri"/>
               </a:rPr>
-              <a:t>60</a:t>
+              <a:t>72</a:t>
             </a:r>
           </a:p>
         </p:txBody>
@@ -14593,7 +14593,7 @@
                 </a:solidFill>
                 <a:latin typeface="Calibri"/>
               </a:rPr>
-              <a:t>FR12  Admin: verify, suspend, remove</a:t>
+              <a:t>FR12  Admin: verify once, integrity check, logged moderation</a:t>
             </a:r>
           </a:p>
         </p:txBody>
@@ -15066,7 +15066,7 @@
                 </a:solidFill>
                 <a:latin typeface="Calibri"/>
               </a:rPr>
-              <a:t>MongoDB Atlas (six collections) and Cloudinary for photos.</a:t>
+              <a:t>MongoDB Atlas (seven collections) and Cloudinary for photos.</a:t>
             </a:r>
           </a:p>
           <a:p>
@@ -15253,7 +15253,7 @@
         </p:nvGraphicFramePr>
         <p:xfrm>
           <a:off x="548640" y="1234440"/>
-          <a:ext cx="11064240" cy="3968496"/>
+          <a:ext cx="11064240" cy="4096512"/>
         </p:xfrm>
         <a:graphic>
           <a:graphicData uri="http://schemas.openxmlformats.org/drawingml/2006/table">
@@ -15266,7 +15266,7 @@
                 <a:gridCol w="5120640"/>
                 <a:gridCol w="4114800"/>
               </a:tblGrid>
-              <a:tr h="566928">
+              <a:tr h="512064">
                 <a:tc>
                   <a:txBody>
                     <a:bodyPr wrap="square"/>
@@ -15334,7 +15334,7 @@
                   </a:tcPr>
                 </a:tc>
               </a:tr>
-              <a:tr h="566928">
+              <a:tr h="512064">
                 <a:tc>
                   <a:txBody>
                     <a:bodyPr wrap="square"/>
@@ -15402,7 +15402,7 @@
                   </a:tcPr>
                 </a:tc>
               </a:tr>
-              <a:tr h="566928">
+              <a:tr h="512064">
                 <a:tc>
                   <a:txBody>
                     <a:bodyPr wrap="square"/>
@@ -15470,7 +15470,7 @@
                   </a:tcPr>
                 </a:tc>
               </a:tr>
-              <a:tr h="566928">
+              <a:tr h="512064">
                 <a:tc>
                   <a:txBody>
                     <a:bodyPr wrap="square"/>
@@ -15538,7 +15538,7 @@
                   </a:tcPr>
                 </a:tc>
               </a:tr>
-              <a:tr h="566928">
+              <a:tr h="512064">
                 <a:tc>
                   <a:txBody>
                     <a:bodyPr wrap="square"/>
@@ -15606,7 +15606,7 @@
                   </a:tcPr>
                 </a:tc>
               </a:tr>
-              <a:tr h="566928">
+              <a:tr h="512064">
                 <a:tc>
                   <a:txBody>
                     <a:bodyPr wrap="square"/>
@@ -15674,7 +15674,7 @@
                   </a:tcPr>
                 </a:tc>
               </a:tr>
-              <a:tr h="566928">
+              <a:tr h="512064">
                 <a:tc>
                   <a:txBody>
                     <a:bodyPr wrap="square"/>
@@ -15742,6 +15742,74 @@
                   </a:tcPr>
                 </a:tc>
               </a:tr>
+              <a:tr h="512064">
+                <a:tc>
+                  <a:txBody>
+                    <a:bodyPr wrap="square"/>
+                    <a:lstStyle/>
+                    <a:p>
+                      <a:r>
+                        <a:rPr sz="1400" b="0">
+                          <a:solidFill>
+                            <a:srgbClr val="232323"/>
+                          </a:solidFill>
+                          <a:latin typeface="Calibri"/>
+                        </a:rPr>
+                        <a:t>AdminLog</a:t>
+                      </a:r>
+                    </a:p>
+                  </a:txBody>
+                  <a:tcPr marL="73152" marR="73152" marT="36576" marB="36576" anchor="ctr">
+                    <a:solidFill>
+                      <a:srgbClr val="FFFFFF"/>
+                    </a:solidFill>
+                  </a:tcPr>
+                </a:tc>
+                <a:tc>
+                  <a:txBody>
+                    <a:bodyPr wrap="square"/>
+                    <a:lstStyle/>
+                    <a:p>
+                      <a:r>
+                        <a:rPr sz="1400" b="0">
+                          <a:solidFill>
+                            <a:srgbClr val="232323"/>
+                          </a:solidFill>
+                          <a:latin typeface="Calibri"/>
+                        </a:rPr>
+                        <a:t>admin, action, target, reason, time</a:t>
+                      </a:r>
+                    </a:p>
+                  </a:txBody>
+                  <a:tcPr marL="73152" marR="73152" marT="36576" marB="36576" anchor="ctr">
+                    <a:solidFill>
+                      <a:srgbClr val="FFFFFF"/>
+                    </a:solidFill>
+                  </a:tcPr>
+                </a:tc>
+                <a:tc>
+                  <a:txBody>
+                    <a:bodyPr wrap="square"/>
+                    <a:lstStyle/>
+                    <a:p>
+                      <a:r>
+                        <a:rPr sz="1400" b="0">
+                          <a:solidFill>
+                            <a:srgbClr val="232323"/>
+                          </a:solidFill>
+                          <a:latin typeface="Calibri"/>
+                        </a:rPr>
+                        <a:t>Every admin action is accountable</a:t>
+                      </a:r>
+                    </a:p>
+                  </a:txBody>
+                  <a:tcPr marL="73152" marR="73152" marT="36576" marB="36576" anchor="ctr">
+                    <a:solidFill>
+                      <a:srgbClr val="FFFFFF"/>
+                    </a:solidFill>
+                  </a:tcPr>
+                </a:tc>
+              </a:tr>
             </a:tbl>
           </a:graphicData>
         </a:graphic>
@@ -15754,7 +15822,7 @@
         </p:nvSpPr>
         <p:spPr>
           <a:xfrm>
-            <a:off x="548640" y="5394960"/>
+            <a:off x="548640" y="5532120"/>
             <a:ext cx="11064240" cy="640080"/>
           </a:xfrm>
           <a:prstGeom prst="rect">
@@ -18135,7 +18203,7 @@
                 </a:solidFill>
                 <a:latin typeface="Calibri"/>
               </a:rPr>
-              <a:t>Statistics, verify, suspend, remove</a:t>
+              <a:t>Verify queue, integrity check, logged moderation</a:t>
             </a:r>
           </a:p>
         </p:txBody>
@@ -19107,7 +19175,7 @@
         </p:nvGraphicFramePr>
         <p:xfrm>
           <a:off x="548640" y="1280160"/>
-          <a:ext cx="11064240" cy="3968496"/>
+          <a:ext cx="11064240" cy="4535424"/>
         </p:xfrm>
         <a:graphic>
           <a:graphicData uri="http://schemas.openxmlformats.org/drawingml/2006/table">
@@ -19316,7 +19384,7 @@
                           </a:solidFill>
                           <a:latin typeface="Calibri"/>
                         </a:rPr>
-                        <a:t>Browsers cannot recognise Nyanja or Bemba</a:t>
+                        <a:t>An admin could verify twice (+15 again) or demote another admin</a:t>
                       </a:r>
                     </a:p>
                   </a:txBody>
@@ -19338,7 +19406,7 @@
                           </a:solidFill>
                           <a:latin typeface="Calibri"/>
                         </a:rPr>
-                        <a:t>Scope narrowed to English, stated openly</a:t>
+                        <a:t>Verify once only; admins protected; every action logged with a reason</a:t>
                       </a:r>
                     </a:p>
                   </a:txBody>
@@ -19362,7 +19430,7 @@
                           </a:solidFill>
                           <a:latin typeface="Calibri"/>
                         </a:rPr>
-                        <a:t>Voice parser missed "ninety five" and "at 100"</a:t>
+                        <a:t>Browsers cannot recognise Nyanja or Bemba</a:t>
                       </a:r>
                     </a:p>
                   </a:txBody>
@@ -19384,7 +19452,7 @@
                           </a:solidFill>
                           <a:latin typeface="Calibri"/>
                         </a:rPr>
-                        <a:t>Rewritten as a separate, tested module</a:t>
+                        <a:t>Scope narrowed to English, stated openly</a:t>
                       </a:r>
                     </a:p>
                   </a:txBody>
@@ -19408,7 +19476,7 @@
                           </a:solidFill>
                           <a:latin typeface="Calibri"/>
                         </a:rPr>
-                        <a:t>Deployment failed (July and September 2026)</a:t>
+                        <a:t>Voice parser missed "ninety five" and "at 100"</a:t>
                       </a:r>
                     </a:p>
                   </a:txBody>
@@ -19430,13 +19498,59 @@
                           </a:solidFill>
                           <a:latin typeface="Calibri"/>
                         </a:rPr>
+                        <a:t>Rewritten as a separate, tested module</a:t>
+                      </a:r>
+                    </a:p>
+                  </a:txBody>
+                  <a:tcPr marL="73152" marR="73152" marT="36576" marB="36576" anchor="ctr">
+                    <a:solidFill>
+                      <a:srgbClr val="EEF2F7"/>
+                    </a:solidFill>
+                  </a:tcPr>
+                </a:tc>
+              </a:tr>
+              <a:tr h="566928">
+                <a:tc>
+                  <a:txBody>
+                    <a:bodyPr wrap="square"/>
+                    <a:lstStyle/>
+                    <a:p>
+                      <a:r>
+                        <a:rPr sz="1500" b="0">
+                          <a:solidFill>
+                            <a:srgbClr val="232323"/>
+                          </a:solidFill>
+                          <a:latin typeface="Calibri"/>
+                        </a:rPr>
+                        <a:t>Deployment failed (July and September 2026)</a:t>
+                      </a:r>
+                    </a:p>
+                  </a:txBody>
+                  <a:tcPr marL="73152" marR="73152" marT="36576" marB="36576" anchor="ctr">
+                    <a:solidFill>
+                      <a:srgbClr val="FFFFFF"/>
+                    </a:solidFill>
+                  </a:tcPr>
+                </a:tc>
+                <a:tc>
+                  <a:txBody>
+                    <a:bodyPr wrap="square"/>
+                    <a:lstStyle/>
+                    <a:p>
+                      <a:r>
+                        <a:rPr sz="1500" b="0">
+                          <a:solidFill>
+                            <a:srgbClr val="232323"/>
+                          </a:solidFill>
+                          <a:latin typeface="Calibri"/>
+                        </a:rPr>
                         <a:t>Found four causes (hard-coded addresses, CORS, cache, routing) and fixed them</a:t>
                       </a:r>
                     </a:p>
                   </a:txBody>
                   <a:tcPr marL="73152" marR="73152" marT="36576" marB="36576" anchor="ctr">
                     <a:solidFill>
-                      <a:srgbClr val="EEF2F7"/>
+                      <a:srgbClr val="FFFFFF"/>
                     </a:solidFill>
                   </a:tcPr>
                 </a:tc>
@@ -20231,7 +20345,7 @@
                 </a:solidFill>
                 <a:latin typeface="Calibri"/>
               </a:rPr>
-              <a:t>60 automated tests, run on every push by GitHub Actions</a:t>
+              <a:t>72 automated tests, run on every push by GitHub Actions</a:t>
             </a:r>
           </a:p>
         </p:txBody>
@@ -22011,7 +22125,7 @@
                 </a:solidFill>
                 <a:latin typeface="Calibri"/>
               </a:rPr>
-              <a:t>All 48 backend and 12 voice-parser tests pass. Full tables: Report Tables 6.1 to 6.3.</a:t>
+              <a:t>All 60 backend and 12 voice-parser tests pass. Full tables: Report Tables 6.1 to 6.3.</a:t>
             </a:r>
           </a:p>
         </p:txBody>
@@ -22243,7 +22357,7 @@
                 </a:solidFill>
                 <a:latin typeface="Calibri"/>
               </a:rPr>
-              <a:t>48/48</a:t>
+              <a:t>60/60</a:t>
             </a:r>
           </a:p>
         </p:txBody>
@@ -24040,7 +24154,7 @@
                 </a:solidFill>
                 <a:latin typeface="Calibri"/>
               </a:rPr>
-              <a:t>48/48 tests incl. most recent block</a:t>
+              <a:t>60/60 tests incl. most recent block</a:t>
             </a:r>
           </a:p>
         </p:txBody>
@@ -25216,7 +25330,7 @@
                 </a:solidFill>
                 <a:latin typeface="Calibri"/>
               </a:rPr>
-              <a:t>60 automated tests, CI, browser checks, system test plan</a:t>
+              <a:t>72 automated tests, CI, browser checks, system test plan</a:t>
             </a:r>
           </a:p>
         </p:txBody>
@@ -28956,7 +29070,7 @@
                 </a:solidFill>
                 <a:latin typeface="Calibri"/>
               </a:rPr>
-              <a:t>60 of 60 automated tests pass; any tampering is detected</a:t>
+              <a:t>72 of 72 automated tests pass; any tampering is detected</a:t>
             </a:r>
           </a:p>
         </p:txBody>
@@ -32372,7 +32486,7 @@
                 </a:solidFill>
                 <a:latin typeface="Calibri"/>
               </a:rPr>
-              <a:t>Verify the seller: +15 and a badge</a:t>
+              <a:t>Integrity tab flags the altered record; verify a seller: +15</a:t>
             </a:r>
           </a:p>
         </p:txBody>

</xml_diff>

<commit_message>
Report and slides: live deployment, phone test results, 15-minute deck
- Report: deployed on 12 October 2026 (abstract, limitations, conclusion,
  Appendix B hosting steps), system tests TC-01/04/06/07/14/16/17 passed on
  the live system plus TC-22 (install on Android), SMS module described,
  new challenges (OTP in production, phone formats, neighbourhood lists,
  install icons), test counts 73 backend + 13 voice = 86
- Slides: same updates; new ZamMarket_Presentation_15min.pptx with 15 of
  the 48 slides for the 15-minute slot

Co-Authored-By: Claude Opus 5.5 <noreply@anthropic.com>
Claude-Session: https://claude.ai/code/session_01TkMBnKe3c5H95DS4zcaeu8
</commit_message>
<xml_diff>
--- a/docs/presentation/ZamMarket_Presentation.pptx
+++ b/docs/presentation/ZamMarket_Presentation.pptx
@@ -1335,7 +1335,7 @@
           <a:lstStyle/>
           <a:p>
             <a:r>
-              <a:t>This was an individual project, so I did all of the work myself, under Mr. Phiri's supervision. In numbers: four agile sprints plus a stabilisation period, eight modules, and 72 automated tests that all pass. The app covers eleven named Lusaka neighbourhoods.</a:t>
+              <a:t>This was an individual project, so I did all of the work myself, under Mr. Phiri's supervision. In numbers: four agile sprints plus a stabilisation period, eight modules, and 86 automated tests that all pass. It is live at zam-market-khaki.vercel.app. The app covers twenty-four Lusaka-area places.</a:t>
             </a:r>
           </a:p>
         </p:txBody>
@@ -1755,7 +1755,7 @@
           <a:lstStyle/>
           <a:p>
             <a:r>
-              <a:t>Some honest challenges. The most interesting: I found a security hole myself during polishing. Anyone could register as an administrator by sending the word 'admin' to the API. Now sign-up only allows buyer or seller, and administrators are created by a script. Deployment failed twice; I traced it to four causes and fixed all four.</a:t>
+              <a:t>Some honest challenges. The most interesting: I found a security hole myself during polishing. Anyone could register as an administrator by sending the word 'admin' to the API. Now sign-up only allows buyer or seller, and administrators are created by a script. Deployment failed twice; I traced it to four causes, fixed all four, and the system is now live.</a:t>
             </a:r>
           </a:p>
         </p:txBody>
@@ -1965,7 +1965,7 @@
           <a:lstStyle/>
           <a:p>
             <a:r>
-              <a:t>The headline numbers. Verifying a thousand-block chain takes about three milliseconds, so checking every chain on every view is affordable. The voice parser went from four of six phrases to passing everything. Lighthouse scores will be added once the system is redeployed.</a:t>
+              <a:t>The headline numbers. Verifying a thousand-block chain takes about three milliseconds, so checking every chain on every view is affordable. The voice parser went from four of six phrases to passing everything. The system is now live, so a Lighthouse audit of the hosted version is the next measurement.</a:t>
             </a:r>
           </a:p>
         </p:txBody>
@@ -2665,7 +2665,7 @@
           <a:lstStyle/>
           <a:p>
             <a:r>
-              <a:t>Five recommendations, in priority order. The first two are about evidence: get it hosted, and test it with real users.</a:t>
+              <a:t>Five recommendations, in priority order. The first is about evidence: test it with real users. The second costs a small top-up, because every SMS provider charges per message.</a:t>
             </a:r>
           </a:p>
         </p:txBody>
@@ -2945,7 +2945,7 @@
           <a:lstStyle/>
           <a:p>
             <a:r>
-              <a:t>DEMO SCRIPT (about 4 minutes). Have two browser windows open before you start: a buyer logged in on one, the seller on the other (or a phone). 1) As buyer: Browse, tap Kanyama, set a price range. 2) As seller: New Listing, Voice, say 'Hardwood charcoal, ten bags, ninety five kwacha each, Kanyama'; show the fields, tap Use This, post. 3) As buyer: open the listing, Message Seller; reply as seller. Turn on airplane mode, send a message and post a listing with a photo; show both waiting (My Listings shows 'Waiting to post'); turn data back on and show both delivered. 4) As buyer: Rate Seller, 5 stars; open the trust page and show the new block. 5) In MongoDB Atlas, edit one trustchains document (change a rating type); refresh the trust page: the score turns into a red 'Record has been altered' warning. 6) As admin: open the Integrity tab; the same seller is flagged and the tab shows a red badge. Undo the edit in Atlas, run the check again and show it clear. Then open the Verify tab and verify a seller; their score rises by 15, and the action appears in the Activity tab. If anything fails, fall back to the screenshots.</a:t>
+              <a:t>DEMO SCRIPT (about 4 minutes). Two minutes before: open the Render /api/health link to wake the server, and keep Render Logs open for registration codes. Have two browser windows open before you start: a buyer logged in on one, the seller on the other (or a phone). 1) As buyer: Browse, tap Kanyama, set a price range. 2) As seller: New Listing, Voice, say 'Hardwood charcoal, ten bags, ninety five kwacha each, Kanyama'; show the fields, tap Use This, post. 3) As buyer: open the listing, Message Seller; reply as seller. Turn on airplane mode, send a message and post a listing with a photo; show both waiting (My Listings shows 'Waiting to post'); turn data back on and show both delivered. 4) As buyer: Rate Seller, 5 stars; open the trust page and show the new block. 5) In MongoDB Atlas, edit one trustchains document (change a rating type); refresh the trust page: the score turns into a red 'Record has been altered' warning. 6) As admin: open the Integrity tab; the same seller is flagged and the tab shows a red badge. Undo the edit in Atlas, run the check again and show it clear. Then open the Verify tab and verify a seller; their score rises by 15, and the action appears in the Activity tab. If anything fails, fall back to the screenshots.</a:t>
             </a:r>
           </a:p>
         </p:txBody>
@@ -14061,7 +14061,7 @@
                 </a:solidFill>
                 <a:latin typeface="Calibri"/>
               </a:rPr>
-              <a:t>72</a:t>
+              <a:t>86</a:t>
             </a:r>
           </a:p>
         </p:txBody>
@@ -14186,7 +14186,7 @@
                 </a:solidFill>
                 <a:latin typeface="Calibri"/>
               </a:rPr>
-              <a:t>11</a:t>
+              <a:t>24</a:t>
             </a:r>
           </a:p>
         </p:txBody>
@@ -14225,7 +14225,7 @@
                 </a:solidFill>
                 <a:latin typeface="Calibri"/>
               </a:rPr>
-              <a:t>Lusaka neighbourhoods
+              <a:t>Lusaka-area places
 supported</a:t>
             </a:r>
           </a:p>
@@ -19544,7 +19544,7 @@
                           </a:solidFill>
                           <a:latin typeface="Calibri"/>
                         </a:rPr>
-                        <a:t>Found four causes (hard-coded addresses, CORS, cache, routing) and fixed them</a:t>
+                        <a:t>Found and fixed four causes; live since 12 October 2026</a:t>
                       </a:r>
                     </a:p>
                   </a:txBody>
@@ -20345,7 +20345,7 @@
                 </a:solidFill>
                 <a:latin typeface="Calibri"/>
               </a:rPr>
-              <a:t>72 automated tests, run on every push by GitHub Actions</a:t>
+              <a:t>86 automated tests, run on every push by GitHub Actions</a:t>
             </a:r>
           </a:p>
         </p:txBody>
@@ -22125,7 +22125,7 @@
                 </a:solidFill>
                 <a:latin typeface="Calibri"/>
               </a:rPr>
-              <a:t>All 60 backend and 12 voice-parser tests pass. Full tables: Report Tables 6.1 to 6.3.</a:t>
+              <a:t>All 73 backend and 13 voice-parser tests pass; the live system passed its phone tests. Full tables: Report Tables 6.1 to 6.3.</a:t>
             </a:r>
           </a:p>
         </p:txBody>
@@ -22357,7 +22357,7 @@
                 </a:solidFill>
                 <a:latin typeface="Calibri"/>
               </a:rPr>
-              <a:t>60/60</a:t>
+              <a:t>73/73</a:t>
             </a:r>
           </a:p>
         </p:txBody>
@@ -22481,7 +22481,7 @@
                 </a:solidFill>
                 <a:latin typeface="Calibri"/>
               </a:rPr>
-              <a:t>12/12</a:t>
+              <a:t>13/13</a:t>
             </a:r>
           </a:p>
         </p:txBody>
@@ -23431,7 +23431,7 @@
                 </a:solidFill>
                 <a:latin typeface="Calibri"/>
               </a:rPr>
-              <a:t>Voice flow in the browser with simulated speech</a:t>
+              <a:t>Live system tested end to end on an Android phone</a:t>
             </a:r>
           </a:p>
           <a:p>
@@ -23945,7 +23945,7 @@
                 </a:solidFill>
                 <a:latin typeface="Calibri"/>
               </a:rPr>
-              <a:t>12/12 parser tests; real-microphone test pending</a:t>
+              <a:t>13/13 parser tests; dictation tested on a phone</a:t>
             </a:r>
           </a:p>
         </p:txBody>
@@ -24154,7 +24154,7 @@
                 </a:solidFill>
                 <a:latin typeface="Calibri"/>
               </a:rPr>
-              <a:t>60/60 tests incl. most recent block</a:t>
+              <a:t>73/73 tests incl. most recent block</a:t>
             </a:r>
           </a:p>
         </p:txBody>
@@ -24574,7 +24574,7 @@
                 </a:solidFill>
                 <a:latin typeface="Calibri"/>
               </a:rPr>
-              <a:t>Automated tests in CI; SUS and Lighthouse pending</a:t>
+              <a:t>Tests in CI; live system tested; SUS pending</a:t>
             </a:r>
           </a:p>
         </p:txBody>
@@ -25330,7 +25330,7 @@
                 </a:solidFill>
                 <a:latin typeface="Calibri"/>
               </a:rPr>
-              <a:t>72 automated tests, CI, browser checks, system test plan</a:t>
+              <a:t>86 automated tests, CI, browser and live phone tests</a:t>
             </a:r>
           </a:p>
         </p:txBody>
@@ -28186,7 +28186,7 @@
                 </a:solidFill>
                 <a:latin typeface="Calibri"/>
               </a:rPr>
-              <a:t>Not yet redeployed: </a:t>
+              <a:t>No paid SMS: </a:t>
             </a:r>
             <a:r>
               <a:rPr sz="1900" b="0" i="0">
@@ -28195,7 +28195,7 @@
                 </a:solidFill>
                 <a:latin typeface="Calibri"/>
               </a:rPr>
-              <a:t>deployment fixes are in the code, but not yet verified on the hosted system</a:t>
+              <a:t>registration codes go to the server log; real SMS is built in and is one setting away</a:t>
             </a:r>
           </a:p>
         </p:txBody>
@@ -29070,7 +29070,7 @@
                 </a:solidFill>
                 <a:latin typeface="Calibri"/>
               </a:rPr>
-              <a:t>72 of 72 automated tests pass; any tampering is detected</a:t>
+              <a:t>86 of 86 tests pass; tampering is detected; live on Vercel and Render</a:t>
             </a:r>
           </a:p>
         </p:txBody>
@@ -30156,7 +30156,7 @@
                 </a:solidFill>
                 <a:latin typeface="Calibri"/>
               </a:rPr>
-              <a:t>Automated tests in CI; usability study pending</a:t>
+              <a:t>Tests in CI and on the live system; usability study pending</a:t>
             </a:r>
           </a:p>
         </p:txBody>
@@ -30395,7 +30395,7 @@
                 </a:solidFill>
                 <a:latin typeface="Calibri"/>
               </a:rPr>
-              <a:t>Redeploy and verify the hosted system using the deployment checklist</a:t>
+              <a:t>Run the usability study with sellers and buyers before wider release</a:t>
             </a:r>
           </a:p>
         </p:txBody>
@@ -30487,7 +30487,7 @@
                 </a:solidFill>
                 <a:latin typeface="Calibri"/>
               </a:rPr>
-              <a:t>Run the usability study with sellers and buyers before wider release</a:t>
+              <a:t>Switch on real SMS through Africa's Talking (MTN, Airtel, Zamtel)</a:t>
             </a:r>
           </a:p>
         </p:txBody>
@@ -30763,7 +30763,7 @@
                 </a:solidFill>
                 <a:latin typeface="Calibri"/>
               </a:rPr>
-              <a:t>Replace simulated OTP with an SMS provider; record seller licences</a:t>
+              <a:t>Record seller forestry licences before verification</a:t>
             </a:r>
           </a:p>
         </p:txBody>
@@ -32554,7 +32554,7 @@
                 </a:solidFill>
                 <a:latin typeface="Calibri"/>
               </a:rPr>
-              <a:t>Backup if the network fails: screenshots on slide 23 and in the report.</a:t>
+              <a:t>Live: zam-market-khaki.vercel.app · Backup if the network fails: screenshots in the report.</a:t>
             </a:r>
           </a:p>
         </p:txBody>
@@ -32903,7 +32903,7 @@
                 </a:solidFill>
                 <a:latin typeface="Calibri"/>
               </a:rPr>
-              <a:t>github.com/john-chola/ZamMarket</a:t>
+              <a:t>zam-market-khaki.vercel.app · github.com/john-chola/ZamMarket</a:t>
             </a:r>
           </a:p>
         </p:txBody>

</xml_diff>